<commit_message>
docs: use recalculated generic box IoU of 0.8554
</commit_message>
<xml_diff>
--- a/docs/Multilond_AI_updated.pptx
+++ b/docs/Multilond_AI_updated.pptx
@@ -2,24 +2,24 @@
 <file path=ppt/presentation.xml><?xml version="1.0" encoding="utf-8"?>
 <p:presentation xmlns:p="http://schemas.openxmlformats.org/presentationml/2006/main">
   <p:sldMasterIdLst>
-    <p:sldMasterId xmlns:r="http://schemas.openxmlformats.org/officeDocument/2006/relationships" id="2147483648" r:id="R71ef730b74114e1a"/>
+    <p:sldMasterId xmlns:r="http://schemas.openxmlformats.org/officeDocument/2006/relationships" id="2147483648" r:id="Rb0c36ab6a5a84e73"/>
   </p:sldMasterIdLst>
   <p:notesMasterIdLst>
-    <p:notesMasterId xmlns:r="http://schemas.openxmlformats.org/officeDocument/2006/relationships" r:id="R56d3fc9d090f4fbd"/>
+    <p:notesMasterId xmlns:r="http://schemas.openxmlformats.org/officeDocument/2006/relationships" r:id="R3c8ea4f19a714397"/>
   </p:notesMasterIdLst>
   <p:sldIdLst>
-    <p:sldId xmlns:r="http://schemas.openxmlformats.org/officeDocument/2006/relationships" id="256" r:id="R4516cf27107747e7"/>
-    <p:sldId xmlns:r="http://schemas.openxmlformats.org/officeDocument/2006/relationships" id="257" r:id="R365e1d5e6356457d"/>
-    <p:sldId xmlns:r="http://schemas.openxmlformats.org/officeDocument/2006/relationships" id="258" r:id="R50ab1a908aff4c93"/>
-    <p:sldId xmlns:r="http://schemas.openxmlformats.org/officeDocument/2006/relationships" id="259" r:id="Rf76eec9def834689"/>
-    <p:sldId xmlns:r="http://schemas.openxmlformats.org/officeDocument/2006/relationships" id="260" r:id="Rb319827024e64032"/>
-    <p:sldId xmlns:r="http://schemas.openxmlformats.org/officeDocument/2006/relationships" id="261" r:id="R37c89e3dec52463d"/>
-    <p:sldId xmlns:r="http://schemas.openxmlformats.org/officeDocument/2006/relationships" id="262" r:id="R568b906599244ed5"/>
-    <p:sldId xmlns:r="http://schemas.openxmlformats.org/officeDocument/2006/relationships" id="263" r:id="R2b0212c3eb4d45fb"/>
-    <p:sldId xmlns:r="http://schemas.openxmlformats.org/officeDocument/2006/relationships" id="264" r:id="R0d3d49c0a0c647a2"/>
-    <p:sldId xmlns:r="http://schemas.openxmlformats.org/officeDocument/2006/relationships" id="265" r:id="R8ba03f18357c4513"/>
-    <p:sldId xmlns:r="http://schemas.openxmlformats.org/officeDocument/2006/relationships" id="266" r:id="Re9355b6fe3c24e38"/>
-    <p:sldId xmlns:r="http://schemas.openxmlformats.org/officeDocument/2006/relationships" id="267" r:id="R1a5cd1d3bdf5464c"/>
+    <p:sldId xmlns:r="http://schemas.openxmlformats.org/officeDocument/2006/relationships" id="256" r:id="R628a1e67909e4c7c"/>
+    <p:sldId xmlns:r="http://schemas.openxmlformats.org/officeDocument/2006/relationships" id="257" r:id="Rcc3ac23148f24add"/>
+    <p:sldId xmlns:r="http://schemas.openxmlformats.org/officeDocument/2006/relationships" id="258" r:id="Re39deede00454bba"/>
+    <p:sldId xmlns:r="http://schemas.openxmlformats.org/officeDocument/2006/relationships" id="259" r:id="R3b25f32464084919"/>
+    <p:sldId xmlns:r="http://schemas.openxmlformats.org/officeDocument/2006/relationships" id="260" r:id="R1528ae77649e4a96"/>
+    <p:sldId xmlns:r="http://schemas.openxmlformats.org/officeDocument/2006/relationships" id="261" r:id="R3ccab0f495714c61"/>
+    <p:sldId xmlns:r="http://schemas.openxmlformats.org/officeDocument/2006/relationships" id="262" r:id="R5fb3304729034bc0"/>
+    <p:sldId xmlns:r="http://schemas.openxmlformats.org/officeDocument/2006/relationships" id="263" r:id="R2b9fe98dc69c4148"/>
+    <p:sldId xmlns:r="http://schemas.openxmlformats.org/officeDocument/2006/relationships" id="264" r:id="Rd46f6848fa8e405d"/>
+    <p:sldId xmlns:r="http://schemas.openxmlformats.org/officeDocument/2006/relationships" id="265" r:id="Red29690bde214ffb"/>
+    <p:sldId xmlns:r="http://schemas.openxmlformats.org/officeDocument/2006/relationships" id="266" r:id="R7b656ed14aba4d31"/>
+    <p:sldId xmlns:r="http://schemas.openxmlformats.org/officeDocument/2006/relationships" id="267" r:id="R5bb5279dbda64e80"/>
   </p:sldIdLst>
   <p:sldSz cx="18288000" cy="10287000"/>
   <p:notesSz cx="6858000" cy="9144000"/>
@@ -736,7 +736,7 @@
           <a:lstStyle xmlns:a="http://schemas.openxmlformats.org/drawingml/2006/main"/>
           <a:p xmlns:a="http://schemas.openxmlformats.org/drawingml/2006/main">
             <a:r>
-              <a:t>2:05–2:45. In the team’s reported rerun of the same 34 MVTec AD cable photos, the generic checklist caught two of 24 defects. It passed almost everything, so zero false alarms alone was misleading. Describing a correct cable raised the catch count to 14, seven times as many. Both runs had zero false alarms on ten clean photos. Targeted checks averaged 5.65 seconds. The reported mean box IoU was 0.62 for positive-overlap detections only. Ten defects still escaped. This small cable experiment does not establish packing-box or factory reliability. The targeted run caught 3/3 cable swaps and 3/3 missing cables in this set; these are subtype catch counts, not precision. The earlier 91.3% IoU and 97.1% mask coverage were from one photo, not sample averages. Sources: team rerun report supplied by the user; https://github.com/acagliol/amdactiii/commit/ad0c66e88bdd35f602c00ffaa5f11fc87b0c9439 ; evaluator averaging behavior in eval/evaluate.py. Raw predictions were not supplied, and this update is not an independent rerun.</a:t>
+              <a:t>2:05–2:45. In the team’s reported rerun of the same 34 MVTec AD cable photos, the generic checklist caught two of 24 defects. It passed almost everything, so zero false alarms alone was misleading. Describing a correct cable raised the catch count to 14, seven times as many. Both runs had zero false alarms on ten clean photos. Targeted checks averaged 5.65 seconds. Generic mean box IoU is 0.8554, recalculated from its two detected boxes. Targeted mean box IoU is 0.6211 across fourteen detected boxes, shown rounded to 0.62. Both means use positive-overlap detections only. Ten defects still escaped. This small cable experiment does not establish packing-box or factory reliability. The targeted run caught 3/3 cable swaps and 3/3 missing cables in this set; these are subtype catch counts, not precision. The earlier 91.3% IoU and 97.1% mask coverage were from one photo, not sample averages. Sources: team rerun report supplied by the user; https://github.com/acagliol/amdactiii/commit/ad0c66e88bdd35f602c00ffaa5f11fc87b0c9439 ; evaluator averaging behavior in eval/evaluate.py. Both per-image CSVs are now available in PR #9 and have been checked for matching image paths and labels. Counts, latency averages and box IoU were recalculated from those records; this is not an independent model rerun. The generic CSV and scorecard store 0.75, but their saved boxes yield 0.8160 and 0.8948, averaging 0.8554. The original CSV and scorecard remain unchanged. Source: https://github.com/acagliol/amdactiii/tree/7b9e5baaf56b1d8d30acccf876d91235f606c098/docs/results . Pixel-mask coverage and endpoint/model settings have not been independently verified.</a:t>
             </a:r>
             <a:endParaRPr/>
           </a:p>
@@ -1444,7 +1444,7 @@
   </p:cSld>
   <p:clrMap bg1="lt1" tx1="dk1" bg2="lt2" tx2="dk2" accent1="accent1" accent2="accent2" accent3="accent3" accent4="accent4" accent5="accent5" accent6="accent6" hlink="hlink" folHlink="folHlink"/>
   <p:sldLayoutIdLst>
-    <p:sldLayoutId xmlns:r="http://schemas.openxmlformats.org/officeDocument/2006/relationships" id="2147483649" r:id="Rba1f0e50a8e94c37"/>
+    <p:sldLayoutId xmlns:r="http://schemas.openxmlformats.org/officeDocument/2006/relationships" id="2147483649" r:id="R71c3649120da431c"/>
   </p:sldLayoutIdLst>
   <p:hf sldNum="0" hdr="0" ftr="0" dt="0"/>
   <p:txStyles>
@@ -2150,7 +2150,7 @@
           <p:cNvPr id="5" name="Image 0">
             <a:extLst xmlns:a="http://schemas.openxmlformats.org/drawingml/2006/main">
               <a:ext uri="{FF2B5EF4-FFF2-40B4-BE49-F238E27FC236}">
-                <a16:creationId xmlns:a16="http://schemas.microsoft.com/office/drawing/2014/main" id="{B8CE0F9E-7CC4-4384-87A5-4B6A1F5DBCED}"/>
+                <a16:creationId xmlns:a16="http://schemas.microsoft.com/office/drawing/2014/main" id="{43C2D294-FEE5-4826-98BC-BB938BBE7633}"/>
               </a:ext>
             </a:extLst>
           </p:cNvPr>
@@ -2160,10 +2160,10 @@
           <p:nvPr/>
         </p:nvPicPr>
         <p:blipFill>
-          <a:blip xmlns:r="http://schemas.openxmlformats.org/officeDocument/2006/relationships" xmlns:a="http://schemas.openxmlformats.org/drawingml/2006/main" r:embed="Rc832de6815274b9b">
+          <a:blip xmlns:r="http://schemas.openxmlformats.org/officeDocument/2006/relationships" xmlns:a="http://schemas.openxmlformats.org/drawingml/2006/main" r:embed="R850aefe5b6a24d35">
             <a:extLst>
               <a:ext uri="{96DAC541-7B7A-43D3-8B79-37D633B846F1}">
-                <asvg:svgBlip xmlns:asvg="http://schemas.microsoft.com/office/drawing/2016/SVG/main" r:embed="R7f4917b8a2b945fe"/>
+                <asvg:svgBlip xmlns:asvg="http://schemas.microsoft.com/office/drawing/2016/SVG/main" r:embed="R75cf33b8239e48b8"/>
               </a:ext>
             </a:extLst>
           </a:blip>
@@ -2894,6 +2894,7 @@
           </a:lstStyle>
           <a:p xmlns:a="http://schemas.openxmlformats.org/drawingml/2006/main">
             <a:pPr>
+              <a:buNone/>
               <a:defRPr sz="2400" b="0">
                 <a:solidFill>
                   <a:srgbClr val="B9BDC2"/>
@@ -2922,7 +2923,7 @@
           <p:cNvPr id="7" name="">
             <a:extLst xmlns:a="http://schemas.openxmlformats.org/drawingml/2006/main">
               <a:ext uri="{FF2B5EF4-FFF2-40B4-BE49-F238E27FC236}">
-                <a16:creationId xmlns:a16="http://schemas.microsoft.com/office/drawing/2014/main" id="{52023A21-8FE5-4EC8-88ED-2F43EE4FC59C}"/>
+                <a16:creationId xmlns:a16="http://schemas.microsoft.com/office/drawing/2014/main" id="{2ED0E806-440A-417B-9B85-0948BED3B713}"/>
               </a:ext>
             </a:extLst>
           </p:cNvPr>
@@ -3365,7 +3366,7 @@
                           <a:ea typeface="Arial"/>
                           <a:cs typeface="Arial"/>
                         </a:rPr>
-                        <a:t>0.75</a:t>
+                        <a:t>0.8554</a:t>
                       </a:r>
                     </a:p>
                   </a:txBody>
@@ -3589,6 +3590,7 @@
           </a:lstStyle>
           <a:p xmlns:a="http://schemas.openxmlformats.org/drawingml/2006/main">
             <a:pPr>
+              <a:buNone/>
               <a:defRPr sz="2850" b="0">
                 <a:solidFill>
                   <a:srgbClr val="F2F2F0"/>
@@ -3657,6 +3659,7 @@
           </a:lstStyle>
           <a:p xmlns:a="http://schemas.openxmlformats.org/drawingml/2006/main">
             <a:pPr>
+              <a:buNone/>
               <a:defRPr sz="1875" b="0">
                 <a:solidFill>
                   <a:srgbClr val="8A8F95"/>
@@ -3675,7 +3678,7 @@
                 <a:ea typeface="Arial"/>
                 <a:cs typeface="Arial"/>
               </a:rPr>
-              <a:t>Team-reported / AMD Token Factory (Radeon Cloud GPUs) / Gemma-4-31B-IT</a:t>
+              <a:t>Team CSV records / AMD Token Factory (Radeon Cloud GPUs) / Gemma-4-31B-IT</a:t>
             </a:r>
           </a:p>
         </p:txBody>
@@ -3725,6 +3728,7 @@
           </a:lstStyle>
           <a:p xmlns:a="http://schemas.openxmlformats.org/drawingml/2006/main">
             <a:pPr>
+              <a:buNone/>
               <a:defRPr sz="1800" b="0">
                 <a:solidFill>
                   <a:srgbClr val="B9BDC2"/>
@@ -3743,7 +3747,31 @@
                 <a:ea typeface="Arial"/>
                 <a:cs typeface="Arial"/>
               </a:rPr>
-              <a:t>*IoU averages positive-overlap detections only. Misses and zero-overlap boxes are excluded. Small sample, not factory validation.</a:t>
+              <a:t>Generic IoU: recalculated from 2 detected boxes. Targeted: 14 detected boxes.</a:t>
+            </a:r>
+          </a:p>
+          <a:p xmlns:a="http://schemas.openxmlformats.org/drawingml/2006/main">
+            <a:pPr>
+              <a:buNone/>
+              <a:defRPr sz="1800" b="0">
+                <a:solidFill>
+                  <a:srgbClr val="B9BDC2"/>
+                </a:solidFill>
+                <a:latin typeface="Arial"/>
+                <a:ea typeface="Arial"/>
+                <a:cs typeface="Arial"/>
+              </a:defRPr>
+            </a:pPr>
+            <a:r>
+              <a:rPr sz="1800" b="0">
+                <a:solidFill>
+                  <a:srgbClr val="B9BDC2"/>
+                </a:solidFill>
+                <a:latin typeface="Arial"/>
+                <a:ea typeface="Arial"/>
+                <a:cs typeface="Arial"/>
+              </a:rPr>
+              <a:t>*Positive-overlap detections only. Misses and zero-overlap boxes excluded. Small sample, not factory validation.</a:t>
             </a:r>
           </a:p>
         </p:txBody>
@@ -3869,7 +3897,7 @@
           <p:cNvPr id="4" name="Image 0">
             <a:extLst xmlns:a="http://schemas.openxmlformats.org/drawingml/2006/main">
               <a:ext uri="{FF2B5EF4-FFF2-40B4-BE49-F238E27FC236}">
-                <a16:creationId xmlns:a16="http://schemas.microsoft.com/office/drawing/2014/main" id="{739D61E7-1AF4-4858-99F7-DE3E2FBC4A12}"/>
+                <a16:creationId xmlns:a16="http://schemas.microsoft.com/office/drawing/2014/main" id="{2AC2A380-1BC7-4BF4-84FF-1C65EDDDB0DC}"/>
               </a:ext>
             </a:extLst>
           </p:cNvPr>
@@ -3879,10 +3907,10 @@
           <p:nvPr/>
         </p:nvPicPr>
         <p:blipFill>
-          <a:blip xmlns:r="http://schemas.openxmlformats.org/officeDocument/2006/relationships" xmlns:a="http://schemas.openxmlformats.org/drawingml/2006/main" r:embed="Rc31cfc9bb74d4a04">
+          <a:blip xmlns:r="http://schemas.openxmlformats.org/officeDocument/2006/relationships" xmlns:a="http://schemas.openxmlformats.org/drawingml/2006/main" r:embed="Rf0d0777061904558">
             <a:extLst>
               <a:ext uri="{96DAC541-7B7A-43D3-8B79-37D633B846F1}">
-                <asvg:svgBlip xmlns:asvg="http://schemas.microsoft.com/office/drawing/2016/SVG/main" r:embed="R5f7be81b8e4f4606"/>
+                <asvg:svgBlip xmlns:asvg="http://schemas.microsoft.com/office/drawing/2016/SVG/main" r:embed="R0e6f8378da794af7"/>
               </a:ext>
             </a:extLst>
           </a:blip>
@@ -6271,7 +6299,7 @@
           <p:cNvPr id="16" name="">
             <a:extLst xmlns:a="http://schemas.openxmlformats.org/drawingml/2006/main">
               <a:ext uri="{FF2B5EF4-FFF2-40B4-BE49-F238E27FC236}">
-                <a16:creationId xmlns:a16="http://schemas.microsoft.com/office/drawing/2014/main" id="{2266E220-D6D2-4FDA-BEAD-62E205AAA794}"/>
+                <a16:creationId xmlns:a16="http://schemas.microsoft.com/office/drawing/2014/main" id="{4E4821D2-17C8-4FC3-AAB8-6A157C6A5902}"/>
               </a:ext>
             </a:extLst>
           </p:cNvPr>
@@ -6281,7 +6309,7 @@
           <p:nvPr/>
         </p:nvPicPr>
         <p:blipFill>
-          <a:blip xmlns:r="http://schemas.openxmlformats.org/officeDocument/2006/relationships" xmlns:a="http://schemas.openxmlformats.org/drawingml/2006/main" r:embed="R63c3d20b2c2d423c"/>
+          <a:blip xmlns:r="http://schemas.openxmlformats.org/officeDocument/2006/relationships" xmlns:a="http://schemas.openxmlformats.org/drawingml/2006/main" r:embed="R49a73b80a27a4b7a"/>
           <a:stretch xmlns:a="http://schemas.openxmlformats.org/drawingml/2006/main"/>
         </p:blipFill>
         <p:spPr>
@@ -8449,6 +8477,7 @@
           </a:lstStyle>
           <a:p xmlns:a="http://schemas.openxmlformats.org/drawingml/2006/main">
             <a:pPr>
+              <a:buNone/>
               <a:defRPr sz="2100" b="0">
                 <a:solidFill>
                   <a:srgbClr val="B9BDC2"/>
@@ -8692,7 +8721,7 @@
           <p:cNvPr id="6" name="">
             <a:extLst xmlns:a="http://schemas.openxmlformats.org/drawingml/2006/main">
               <a:ext uri="{FF2B5EF4-FFF2-40B4-BE49-F238E27FC236}">
-                <a16:creationId xmlns:a16="http://schemas.microsoft.com/office/drawing/2014/main" id="{7D45F23A-DDCF-4C5D-BC9F-D7095FB248D5}"/>
+                <a16:creationId xmlns:a16="http://schemas.microsoft.com/office/drawing/2014/main" id="{96D1FEA9-36B5-45E9-8B36-9F87A4B91E9E}"/>
               </a:ext>
             </a:extLst>
           </p:cNvPr>
@@ -8702,7 +8731,7 @@
           <p:nvPr/>
         </p:nvPicPr>
         <p:blipFill>
-          <a:blip xmlns:r="http://schemas.openxmlformats.org/officeDocument/2006/relationships" xmlns:a="http://schemas.openxmlformats.org/drawingml/2006/main" r:embed="R6557e62de97a43ab"/>
+          <a:blip xmlns:r="http://schemas.openxmlformats.org/officeDocument/2006/relationships" xmlns:a="http://schemas.openxmlformats.org/drawingml/2006/main" r:embed="R67884e0b536e41e3"/>
           <a:stretch xmlns:a="http://schemas.openxmlformats.org/drawingml/2006/main"/>
         </p:blipFill>
         <p:spPr>
@@ -8760,6 +8789,7 @@
           </a:lstStyle>
           <a:p xmlns:a="http://schemas.openxmlformats.org/drawingml/2006/main">
             <a:pPr>
+              <a:buNone/>
               <a:defRPr sz="3000" b="0">
                 <a:solidFill>
                   <a:srgbClr val="F2F2F0"/>
@@ -8828,6 +8858,7 @@
           </a:lstStyle>
           <a:p xmlns:a="http://schemas.openxmlformats.org/drawingml/2006/main">
             <a:pPr>
+              <a:buNone/>
               <a:defRPr sz="2400" b="0">
                 <a:solidFill>
                   <a:srgbClr val="B9BDC2"/>
@@ -8896,6 +8927,7 @@
           </a:lstStyle>
           <a:p xmlns:a="http://schemas.openxmlformats.org/drawingml/2006/main">
             <a:pPr>
+              <a:buNone/>
               <a:defRPr sz="2700" b="0">
                 <a:solidFill>
                   <a:srgbClr val="F2F2F0"/>
@@ -8964,6 +8996,7 @@
           </a:lstStyle>
           <a:p xmlns:a="http://schemas.openxmlformats.org/drawingml/2006/main">
             <a:pPr>
+              <a:buNone/>
               <a:defRPr sz="2400" b="0">
                 <a:solidFill>
                   <a:srgbClr val="B9BDC2"/>
@@ -9032,6 +9065,7 @@
           </a:lstStyle>
           <a:p xmlns:a="http://schemas.openxmlformats.org/drawingml/2006/main">
             <a:pPr>
+              <a:buNone/>
               <a:defRPr sz="1800" b="0">
                 <a:solidFill>
                   <a:srgbClr val="8A8F95"/>

</xml_diff>

<commit_message>
docs: keep historical model attribution in notes and simplify results slide
</commit_message>
<xml_diff>
--- a/docs/Multilond_AI_updated.pptx
+++ b/docs/Multilond_AI_updated.pptx
@@ -2,24 +2,24 @@
 <file path=ppt/presentation.xml><?xml version="1.0" encoding="utf-8"?>
 <p:presentation xmlns:p="http://schemas.openxmlformats.org/presentationml/2006/main">
   <p:sldMasterIdLst>
-    <p:sldMasterId xmlns:r="http://schemas.openxmlformats.org/officeDocument/2006/relationships" id="2147483648" r:id="R4f73799d0d834269"/>
+    <p:sldMasterId xmlns:r="http://schemas.openxmlformats.org/officeDocument/2006/relationships" id="2147483648" r:id="R28ec6f0bb65649de"/>
   </p:sldMasterIdLst>
   <p:notesMasterIdLst>
-    <p:notesMasterId xmlns:r="http://schemas.openxmlformats.org/officeDocument/2006/relationships" r:id="Raaa796a054024e39"/>
+    <p:notesMasterId xmlns:r="http://schemas.openxmlformats.org/officeDocument/2006/relationships" r:id="R7757d86281844570"/>
   </p:notesMasterIdLst>
   <p:sldIdLst>
-    <p:sldId xmlns:r="http://schemas.openxmlformats.org/officeDocument/2006/relationships" id="256" r:id="Rdf3bf6542e49406c"/>
-    <p:sldId xmlns:r="http://schemas.openxmlformats.org/officeDocument/2006/relationships" id="257" r:id="R2188810843b14a3d"/>
-    <p:sldId xmlns:r="http://schemas.openxmlformats.org/officeDocument/2006/relationships" id="258" r:id="R2a827a330b764882"/>
-    <p:sldId xmlns:r="http://schemas.openxmlformats.org/officeDocument/2006/relationships" id="259" r:id="Rad4d7db18c294b5e"/>
-    <p:sldId xmlns:r="http://schemas.openxmlformats.org/officeDocument/2006/relationships" id="260" r:id="Rd6af585afa314e7f"/>
-    <p:sldId xmlns:r="http://schemas.openxmlformats.org/officeDocument/2006/relationships" id="261" r:id="R7b70f3feca7b4dc6"/>
-    <p:sldId xmlns:r="http://schemas.openxmlformats.org/officeDocument/2006/relationships" id="262" r:id="R729554653b3e45d8"/>
-    <p:sldId xmlns:r="http://schemas.openxmlformats.org/officeDocument/2006/relationships" id="263" r:id="Redc88bfed234451a"/>
-    <p:sldId xmlns:r="http://schemas.openxmlformats.org/officeDocument/2006/relationships" id="264" r:id="R299a12f9b82a4713"/>
-    <p:sldId xmlns:r="http://schemas.openxmlformats.org/officeDocument/2006/relationships" id="265" r:id="Rc48fdced316f4883"/>
-    <p:sldId xmlns:r="http://schemas.openxmlformats.org/officeDocument/2006/relationships" id="266" r:id="Rafec10769990446e"/>
-    <p:sldId xmlns:r="http://schemas.openxmlformats.org/officeDocument/2006/relationships" id="267" r:id="Ra837cac0fb2246cd"/>
+    <p:sldId xmlns:r="http://schemas.openxmlformats.org/officeDocument/2006/relationships" id="256" r:id="Rc6f634bc89c644c1"/>
+    <p:sldId xmlns:r="http://schemas.openxmlformats.org/officeDocument/2006/relationships" id="257" r:id="R69b63c985337435b"/>
+    <p:sldId xmlns:r="http://schemas.openxmlformats.org/officeDocument/2006/relationships" id="258" r:id="R96ba637373534d77"/>
+    <p:sldId xmlns:r="http://schemas.openxmlformats.org/officeDocument/2006/relationships" id="259" r:id="R13b6c292f4844f5f"/>
+    <p:sldId xmlns:r="http://schemas.openxmlformats.org/officeDocument/2006/relationships" id="260" r:id="R6984d97296f24987"/>
+    <p:sldId xmlns:r="http://schemas.openxmlformats.org/officeDocument/2006/relationships" id="261" r:id="R8178e63c7969456d"/>
+    <p:sldId xmlns:r="http://schemas.openxmlformats.org/officeDocument/2006/relationships" id="262" r:id="Ra85334253fdc4633"/>
+    <p:sldId xmlns:r="http://schemas.openxmlformats.org/officeDocument/2006/relationships" id="263" r:id="Rb504b3cab57742ed"/>
+    <p:sldId xmlns:r="http://schemas.openxmlformats.org/officeDocument/2006/relationships" id="264" r:id="R29426286a9734701"/>
+    <p:sldId xmlns:r="http://schemas.openxmlformats.org/officeDocument/2006/relationships" id="265" r:id="R0bf7bcefcc3a4923"/>
+    <p:sldId xmlns:r="http://schemas.openxmlformats.org/officeDocument/2006/relationships" id="266" r:id="R3ae590fb0f124a8b"/>
+    <p:sldId xmlns:r="http://schemas.openxmlformats.org/officeDocument/2006/relationships" id="267" r:id="Rb4c7b6c742a1438b"/>
   </p:sldIdLst>
   <p:sldSz cx="18288000" cy="10287000"/>
   <p:notesSz cx="6858000" cy="9144000"/>
@@ -1444,7 +1444,7 @@
   </p:cSld>
   <p:clrMap bg1="lt1" tx1="dk1" bg2="lt2" tx2="dk2" accent1="accent1" accent2="accent2" accent3="accent3" accent4="accent4" accent5="accent5" accent6="accent6" hlink="hlink" folHlink="folHlink"/>
   <p:sldLayoutIdLst>
-    <p:sldLayoutId xmlns:r="http://schemas.openxmlformats.org/officeDocument/2006/relationships" id="2147483649" r:id="R2153167e1e3a487c"/>
+    <p:sldLayoutId xmlns:r="http://schemas.openxmlformats.org/officeDocument/2006/relationships" id="2147483649" r:id="R20aad6d3b94f4ccb"/>
   </p:sldLayoutIdLst>
   <p:hf sldNum="0" hdr="0" ftr="0" dt="0"/>
   <p:txStyles>
@@ -2150,7 +2150,7 @@
           <p:cNvPr id="5" name="Image 0">
             <a:extLst xmlns:a="http://schemas.openxmlformats.org/drawingml/2006/main">
               <a:ext uri="{FF2B5EF4-FFF2-40B4-BE49-F238E27FC236}">
-                <a16:creationId xmlns:a16="http://schemas.microsoft.com/office/drawing/2014/main" id="{CA38BCE4-0CDF-4556-B922-3227AE5BD2D1}"/>
+                <a16:creationId xmlns:a16="http://schemas.microsoft.com/office/drawing/2014/main" id="{00B8C62E-A010-49A1-8433-D4723C1DE4E6}"/>
               </a:ext>
             </a:extLst>
           </p:cNvPr>
@@ -2160,10 +2160,10 @@
           <p:nvPr/>
         </p:nvPicPr>
         <p:blipFill>
-          <a:blip xmlns:r="http://schemas.openxmlformats.org/officeDocument/2006/relationships" xmlns:a="http://schemas.openxmlformats.org/drawingml/2006/main" r:embed="R199894ca2deb4e2a">
+          <a:blip xmlns:r="http://schemas.openxmlformats.org/officeDocument/2006/relationships" xmlns:a="http://schemas.openxmlformats.org/drawingml/2006/main" r:embed="R17484af63094480f">
             <a:extLst>
               <a:ext uri="{96DAC541-7B7A-43D3-8B79-37D633B846F1}">
-                <asvg:svgBlip xmlns:asvg="http://schemas.microsoft.com/office/drawing/2016/SVG/main" r:embed="R30906636df664413"/>
+                <asvg:svgBlip xmlns:asvg="http://schemas.microsoft.com/office/drawing/2016/SVG/main" r:embed="R40410f01aec34e4e"/>
               </a:ext>
             </a:extLst>
           </a:blip>
@@ -2913,7 +2913,7 @@
                 <a:ea typeface="Arial"/>
                 <a:cs typeface="Arial"/>
               </a:rPr>
-              <a:t>Same 34 cable photos: 24 defective, 10 clean / measured with Gemma 4</a:t>
+              <a:t>Same 34 cable photos: 24 defective, 10 clean</a:t>
             </a:r>
           </a:p>
         </p:txBody>
@@ -2923,7 +2923,7 @@
           <p:cNvPr id="7" name="">
             <a:extLst xmlns:a="http://schemas.openxmlformats.org/drawingml/2006/main">
               <a:ext uri="{FF2B5EF4-FFF2-40B4-BE49-F238E27FC236}">
-                <a16:creationId xmlns:a16="http://schemas.microsoft.com/office/drawing/2014/main" id="{966858B9-FBE7-46C2-8605-F6C2326A40A3}"/>
+                <a16:creationId xmlns:a16="http://schemas.microsoft.com/office/drawing/2014/main" id="{F08C56E8-CD13-4CCF-98A7-80E57210A7C7}"/>
               </a:ext>
             </a:extLst>
           </p:cNvPr>
@@ -3678,7 +3678,7 @@
                 <a:ea typeface="Arial"/>
                 <a:cs typeface="Arial"/>
               </a:rPr>
-              <a:t>Measured with Gemma 4 / AMD Token Factory (Radeon Cloud GPUs)</a:t>
+              <a:t>Historical cable benchmark / AMD Token Factory (Radeon Cloud GPUs)</a:t>
             </a:r>
           </a:p>
         </p:txBody>
@@ -3897,7 +3897,7 @@
           <p:cNvPr id="4" name="Image 0">
             <a:extLst xmlns:a="http://schemas.openxmlformats.org/drawingml/2006/main">
               <a:ext uri="{FF2B5EF4-FFF2-40B4-BE49-F238E27FC236}">
-                <a16:creationId xmlns:a16="http://schemas.microsoft.com/office/drawing/2014/main" id="{1BE982FB-F262-4C83-B187-ECBAEA0C8CC4}"/>
+                <a16:creationId xmlns:a16="http://schemas.microsoft.com/office/drawing/2014/main" id="{22870ABD-C5A1-4C79-93F9-1CFD96E3F09D}"/>
               </a:ext>
             </a:extLst>
           </p:cNvPr>
@@ -3907,10 +3907,10 @@
           <p:nvPr/>
         </p:nvPicPr>
         <p:blipFill>
-          <a:blip xmlns:r="http://schemas.openxmlformats.org/officeDocument/2006/relationships" xmlns:a="http://schemas.openxmlformats.org/drawingml/2006/main" r:embed="R6a6a2484482f4b36">
+          <a:blip xmlns:r="http://schemas.openxmlformats.org/officeDocument/2006/relationships" xmlns:a="http://schemas.openxmlformats.org/drawingml/2006/main" r:embed="Rc76e366c55f24692">
             <a:extLst>
               <a:ext uri="{96DAC541-7B7A-43D3-8B79-37D633B846F1}">
-                <asvg:svgBlip xmlns:asvg="http://schemas.microsoft.com/office/drawing/2016/SVG/main" r:embed="R318d6902bb7e4558"/>
+                <asvg:svgBlip xmlns:asvg="http://schemas.microsoft.com/office/drawing/2016/SVG/main" r:embed="R1a6654423afb4347"/>
               </a:ext>
             </a:extLst>
           </a:blip>
@@ -6299,7 +6299,7 @@
           <p:cNvPr id="16" name="">
             <a:extLst xmlns:a="http://schemas.openxmlformats.org/drawingml/2006/main">
               <a:ext uri="{FF2B5EF4-FFF2-40B4-BE49-F238E27FC236}">
-                <a16:creationId xmlns:a16="http://schemas.microsoft.com/office/drawing/2014/main" id="{F089800E-77EB-4422-91EA-26BFB7FAD3F8}"/>
+                <a16:creationId xmlns:a16="http://schemas.microsoft.com/office/drawing/2014/main" id="{C089BC41-4A8F-4625-B410-C70EE91B60B0}"/>
               </a:ext>
             </a:extLst>
           </p:cNvPr>
@@ -6309,7 +6309,7 @@
           <p:nvPr/>
         </p:nvPicPr>
         <p:blipFill>
-          <a:blip xmlns:r="http://schemas.openxmlformats.org/officeDocument/2006/relationships" xmlns:a="http://schemas.openxmlformats.org/drawingml/2006/main" r:embed="Re2db13ba33914458"/>
+          <a:blip xmlns:r="http://schemas.openxmlformats.org/officeDocument/2006/relationships" xmlns:a="http://schemas.openxmlformats.org/drawingml/2006/main" r:embed="Rbed1f8a7fe7c43e4"/>
           <a:stretch xmlns:a="http://schemas.openxmlformats.org/drawingml/2006/main"/>
         </p:blipFill>
         <p:spPr>
@@ -8546,6 +8546,7 @@
           </a:lstStyle>
           <a:p xmlns:a="http://schemas.openxmlformats.org/drawingml/2006/main">
             <a:pPr>
+              <a:buNone/>
               <a:defRPr sz="2400">
                 <a:solidFill>
                   <a:srgbClr val="F2F2F0"/>
@@ -8789,7 +8790,7 @@
           <p:cNvPr id="6" name="">
             <a:extLst xmlns:a="http://schemas.openxmlformats.org/drawingml/2006/main">
               <a:ext uri="{FF2B5EF4-FFF2-40B4-BE49-F238E27FC236}">
-                <a16:creationId xmlns:a16="http://schemas.microsoft.com/office/drawing/2014/main" id="{177F5CD6-42CB-4EBE-9FAE-5742952685F6}"/>
+                <a16:creationId xmlns:a16="http://schemas.microsoft.com/office/drawing/2014/main" id="{68D0996D-F920-49E9-B7DA-A3A9330D0C36}"/>
               </a:ext>
             </a:extLst>
           </p:cNvPr>
@@ -8799,7 +8800,7 @@
           <p:nvPr/>
         </p:nvPicPr>
         <p:blipFill>
-          <a:blip xmlns:r="http://schemas.openxmlformats.org/officeDocument/2006/relationships" xmlns:a="http://schemas.openxmlformats.org/drawingml/2006/main" r:embed="R1bc4b25858f3415f"/>
+          <a:blip xmlns:r="http://schemas.openxmlformats.org/officeDocument/2006/relationships" xmlns:a="http://schemas.openxmlformats.org/drawingml/2006/main" r:embed="R3fbbc5f575574124"/>
           <a:stretch xmlns:a="http://schemas.openxmlformats.org/drawingml/2006/main"/>
         </p:blipFill>
         <p:spPr>

</xml_diff>